<commit_message>
台割 final: calm muted palette
Co-Authored-By: Claude Opus 5.5 <noreply@anthropic.com>
Claude-Session: https://claude.ai/code/session_01RaAHJjFzQLBQzv3hdCW4ED
</commit_message>
<xml_diff>
--- a/cover-proposals/daiwari/final/final_daiwari_editable.pptx
+++ b/cover-proposals/daiwari/final/final_daiwari_editable.pptx
@@ -2712,7 +2712,7 @@
         <p:spPr>
           <a:xfrm>
             <a:off x="3810000" y="10261600"/>
-            <a:ext cx="6180534" cy="152400"/>
+            <a:ext cx="5549900" cy="152400"/>
           </a:xfrm>
           <a:prstGeom prst="rect">
             <a:avLst/>
@@ -2738,7 +2738,7 @@
                 <a:ea typeface="Yu Gothic" pitchFamily="34" charset="-122"/>
                 <a:cs typeface="Yu Gothic" pitchFamily="34" charset="-120"/>
               </a:rPr>
-              <a:t>台割 完成版（構成確認用・PwC様レビュー10/2反映）— 青ラベル＝改善点／色は台割用（緑＝資源投資・橙＝トレーディング）で表紙3案とは無関係</a:t>
+              <a:t>台割 完成版（構成確認用・PwC様レビュー10/2反映）— 色は台割用（深緑＝資源投資・黄土＝トレーディング）で表紙3案とは無関係</a:t>
             </a:r>
             <a:endParaRPr lang="en-US" sz="660" dirty="0"/>
           </a:p>
@@ -3388,7 +3388,7 @@
           <a:noFill/>
           <a:ln w="25400">
             <a:solidFill>
-              <a:srgbClr val="1D6B73"/>
+              <a:srgbClr val="34494E"/>
             </a:solidFill>
             <a:prstDash val="solid"/>
           </a:ln>
@@ -3409,7 +3409,7 @@
             <a:avLst/>
           </a:prstGeom>
           <a:solidFill>
-            <a:srgbClr val="E8F3F3"/>
+            <a:srgbClr val="EEF1F0"/>
           </a:solidFill>
           <a:ln/>
         </p:spPr>
@@ -3426,7 +3426,7 @@
             <a:r>
               <a:rPr lang="en-US" sz="700" b="1" dirty="0">
                 <a:solidFill>
-                  <a:srgbClr val="1D6B73"/>
+                  <a:srgbClr val="34494E"/>
                 </a:solidFill>
                 <a:latin typeface="Yu Gothic" pitchFamily="34" charset="0"/>
                 <a:ea typeface="Yu Gothic" pitchFamily="34" charset="-122"/>
@@ -3475,7 +3475,7 @@
           <a:noFill/>
           <a:ln w="25400">
             <a:solidFill>
-              <a:srgbClr val="1D6B73"/>
+              <a:srgbClr val="34494E"/>
             </a:solidFill>
             <a:prstDash val="solid"/>
           </a:ln>
@@ -3496,7 +3496,7 @@
             <a:avLst/>
           </a:prstGeom>
           <a:solidFill>
-            <a:srgbClr val="E8F3F3"/>
+            <a:srgbClr val="EEF1F0"/>
           </a:solidFill>
           <a:ln/>
         </p:spPr>
@@ -3513,7 +3513,7 @@
             <a:r>
               <a:rPr lang="en-US" sz="700" b="1" dirty="0">
                 <a:solidFill>
-                  <a:srgbClr val="1D6B73"/>
+                  <a:srgbClr val="34494E"/>
                 </a:solidFill>
                 <a:latin typeface="Yu Gothic" pitchFamily="34" charset="0"/>
                 <a:ea typeface="Yu Gothic" pitchFamily="34" charset="-122"/>
@@ -3562,7 +3562,7 @@
           <a:noFill/>
           <a:ln w="25400">
             <a:solidFill>
-              <a:srgbClr val="1D6B73"/>
+              <a:srgbClr val="34494E"/>
             </a:solidFill>
             <a:prstDash val="solid"/>
           </a:ln>
@@ -3583,7 +3583,7 @@
             <a:avLst/>
           </a:prstGeom>
           <a:solidFill>
-            <a:srgbClr val="E8F3F3"/>
+            <a:srgbClr val="EEF1F0"/>
           </a:solidFill>
           <a:ln/>
         </p:spPr>
@@ -3600,7 +3600,7 @@
             <a:r>
               <a:rPr lang="en-US" sz="700" b="1" dirty="0">
                 <a:solidFill>
-                  <a:srgbClr val="1D6B73"/>
+                  <a:srgbClr val="34494E"/>
                 </a:solidFill>
                 <a:latin typeface="Yu Gothic" pitchFamily="34" charset="0"/>
                 <a:ea typeface="Yu Gothic" pitchFamily="34" charset="-122"/>
@@ -3827,11 +3827,11 @@
             <a:avLst/>
           </a:prstGeom>
           <a:solidFill>
-            <a:srgbClr val="1D6B73"/>
+            <a:srgbClr val="34494E"/>
           </a:solidFill>
           <a:ln w="12700">
             <a:solidFill>
-              <a:srgbClr val="1D6B73"/>
+              <a:srgbClr val="34494E"/>
             </a:solidFill>
             <a:prstDash val="solid"/>
           </a:ln>
@@ -4344,7 +4344,7 @@
             <a:r>
               <a:rPr lang="en-US" sz="800" dirty="0">
                 <a:solidFill>
-                  <a:srgbClr val="1D6B73"/>
+                  <a:srgbClr val="34494E"/>
                 </a:solidFill>
                 <a:latin typeface="Yu Gothic" pitchFamily="34" charset="0"/>
                 <a:ea typeface="Yu Gothic" pitchFamily="34" charset="-122"/>
@@ -4413,7 +4413,7 @@
             <a:avLst/>
           </a:prstGeom>
           <a:solidFill>
-            <a:srgbClr val="1D6B73"/>
+            <a:srgbClr val="34494E"/>
           </a:solidFill>
           <a:ln/>
         </p:spPr>
@@ -4475,7 +4475,7 @@
             <a:avLst/>
           </a:prstGeom>
           <a:solidFill>
-            <a:srgbClr val="9CC58C"/>
+            <a:srgbClr val="B9C2B4"/>
           </a:solidFill>
           <a:ln/>
         </p:spPr>
@@ -4537,7 +4537,7 @@
             <a:avLst/>
           </a:prstGeom>
           <a:solidFill>
-            <a:srgbClr val="ECC27A"/>
+            <a:srgbClr val="D6CBB8"/>
           </a:solidFill>
           <a:ln/>
         </p:spPr>
@@ -4599,7 +4599,7 @@
             <a:avLst/>
           </a:prstGeom>
           <a:solidFill>
-            <a:srgbClr val="E7A98A"/>
+            <a:srgbClr val="CFC4BD"/>
           </a:solidFill>
           <a:ln/>
         </p:spPr>
@@ -4661,7 +4661,7 @@
             <a:avLst/>
           </a:prstGeom>
           <a:solidFill>
-            <a:srgbClr val="8FBCD9"/>
+            <a:srgbClr val="BCC6CB"/>
           </a:solidFill>
           <a:ln/>
         </p:spPr>
@@ -4933,7 +4933,7 @@
             <a:avLst/>
           </a:prstGeom>
           <a:solidFill>
-            <a:srgbClr val="2A6FB0"/>
+            <a:srgbClr val="6D7D86"/>
           </a:solidFill>
           <a:ln/>
         </p:spPr>
@@ -5016,11 +5016,11 @@
             <a:avLst/>
           </a:prstGeom>
           <a:solidFill>
-            <a:srgbClr val="1D6B73"/>
+            <a:srgbClr val="34494E"/>
           </a:solidFill>
           <a:ln w="12700">
             <a:solidFill>
-              <a:srgbClr val="1D6B73"/>
+              <a:srgbClr val="34494E"/>
             </a:solidFill>
             <a:prstDash val="solid"/>
           </a:ln>
@@ -5178,11 +5178,11 @@
             <a:avLst/>
           </a:prstGeom>
           <a:solidFill>
-            <a:srgbClr val="E8F3F3"/>
+            <a:srgbClr val="EEF1F0"/>
           </a:solidFill>
           <a:ln w="12700">
             <a:solidFill>
-              <a:srgbClr val="1D6B73"/>
+              <a:srgbClr val="34494E"/>
             </a:solidFill>
             <a:prstDash val="solid"/>
           </a:ln>
@@ -5220,7 +5220,7 @@
             <a:r>
               <a:rPr lang="en-US" sz="580" dirty="0">
                 <a:solidFill>
-                  <a:srgbClr val="1D6B73"/>
+                  <a:srgbClr val="34494E"/>
                 </a:solidFill>
                 <a:latin typeface="Yu Gothic" pitchFamily="34" charset="0"/>
                 <a:ea typeface="Yu Gothic" pitchFamily="34" charset="-122"/>
@@ -5270,11 +5270,11 @@
             <a:avLst/>
           </a:prstGeom>
           <a:solidFill>
-            <a:srgbClr val="E8F3F3"/>
+            <a:srgbClr val="EEF1F0"/>
           </a:solidFill>
           <a:ln w="12700">
             <a:solidFill>
-              <a:srgbClr val="1D6B73"/>
+              <a:srgbClr val="34494E"/>
             </a:solidFill>
             <a:prstDash val="solid"/>
           </a:ln>
@@ -5312,7 +5312,7 @@
             <a:r>
               <a:rPr lang="en-US" sz="580" dirty="0">
                 <a:solidFill>
-                  <a:srgbClr val="1D6B73"/>
+                  <a:srgbClr val="34494E"/>
                 </a:solidFill>
                 <a:latin typeface="Yu Gothic" pitchFamily="34" charset="0"/>
                 <a:ea typeface="Yu Gothic" pitchFamily="34" charset="-122"/>
@@ -5362,11 +5362,11 @@
             <a:avLst/>
           </a:prstGeom>
           <a:solidFill>
-            <a:srgbClr val="FBF0DD"/>
+            <a:srgbClr val="F5F0E8"/>
           </a:solidFill>
           <a:ln w="12700">
             <a:solidFill>
-              <a:srgbClr val="D08A1E"/>
+              <a:srgbClr val="A88A5C"/>
             </a:solidFill>
             <a:prstDash val="solid"/>
           </a:ln>
@@ -5404,7 +5404,7 @@
             <a:r>
               <a:rPr lang="en-US" sz="580" dirty="0">
                 <a:solidFill>
-                  <a:srgbClr val="D08A1E"/>
+                  <a:srgbClr val="A88A5C"/>
                 </a:solidFill>
                 <a:latin typeface="Yu Gothic" pitchFamily="34" charset="0"/>
                 <a:ea typeface="Yu Gothic" pitchFamily="34" charset="-122"/>
@@ -6025,7 +6025,7 @@
             <a:avLst/>
           </a:prstGeom>
           <a:solidFill>
-            <a:srgbClr val="2A6FB0"/>
+            <a:srgbClr val="6D7D86"/>
           </a:solidFill>
           <a:ln/>
         </p:spPr>
@@ -6189,7 +6189,7 @@
             <a:r>
               <a:rPr lang="en-US" sz="580" dirty="0">
                 <a:solidFill>
-                  <a:srgbClr val="3D3F42"/>
+                  <a:srgbClr val="4A4C4F"/>
                 </a:solidFill>
                 <a:latin typeface="Yu Gothic" pitchFamily="34" charset="0"/>
                 <a:ea typeface="Yu Gothic" pitchFamily="34" charset="-122"/>
@@ -6223,7 +6223,7 @@
             <a:r>
               <a:rPr lang="en-US" sz="580" dirty="0">
                 <a:solidFill>
-                  <a:srgbClr val="B8693A"/>
+                  <a:srgbClr val="9C7360"/>
                 </a:solidFill>
                 <a:latin typeface="Yu Gothic" pitchFamily="34" charset="0"/>
                 <a:ea typeface="Yu Gothic" pitchFamily="34" charset="-122"/>
@@ -6541,7 +6541,7 @@
           <a:noFill/>
           <a:ln w="12700">
             <a:solidFill>
-              <a:srgbClr val="1D6B73"/>
+              <a:srgbClr val="34494E"/>
             </a:solidFill>
             <a:prstDash val="solid"/>
           </a:ln>
@@ -6566,7 +6566,7 @@
           </a:solidFill>
           <a:ln w="25400">
             <a:solidFill>
-              <a:srgbClr val="1D6B73"/>
+              <a:srgbClr val="34494E"/>
             </a:solidFill>
             <a:prstDash val="solid"/>
           </a:ln>
@@ -6602,7 +6602,7 @@
             <a:r>
               <a:rPr lang="en-US" sz="600" b="1" dirty="0">
                 <a:solidFill>
-                  <a:srgbClr val="1D6B73"/>
+                  <a:srgbClr val="34494E"/>
                 </a:solidFill>
                 <a:latin typeface="Yu Gothic" pitchFamily="34" charset="0"/>
                 <a:ea typeface="Yu Gothic" pitchFamily="34" charset="-122"/>
@@ -6622,7 +6622,7 @@
             <a:r>
               <a:rPr lang="en-US" sz="600" b="1" dirty="0">
                 <a:solidFill>
-                  <a:srgbClr val="1D6B73"/>
+                  <a:srgbClr val="34494E"/>
                 </a:solidFill>
                 <a:latin typeface="Yu Gothic" pitchFamily="34" charset="0"/>
                 <a:ea typeface="Yu Gothic" pitchFamily="34" charset="-122"/>
@@ -6653,7 +6653,7 @@
           </a:solidFill>
           <a:ln w="25400">
             <a:solidFill>
-              <a:srgbClr val="1D6B73"/>
+              <a:srgbClr val="34494E"/>
             </a:solidFill>
             <a:prstDash val="solid"/>
           </a:ln>
@@ -6689,7 +6689,7 @@
             <a:r>
               <a:rPr lang="en-US" sz="600" b="1" dirty="0">
                 <a:solidFill>
-                  <a:srgbClr val="1D6B73"/>
+                  <a:srgbClr val="34494E"/>
                 </a:solidFill>
                 <a:latin typeface="Yu Gothic" pitchFamily="34" charset="0"/>
                 <a:ea typeface="Yu Gothic" pitchFamily="34" charset="-122"/>
@@ -6720,7 +6720,7 @@
           </a:solidFill>
           <a:ln w="25400">
             <a:solidFill>
-              <a:srgbClr val="1D6B73"/>
+              <a:srgbClr val="34494E"/>
             </a:solidFill>
             <a:prstDash val="solid"/>
           </a:ln>
@@ -6756,7 +6756,7 @@
             <a:r>
               <a:rPr lang="en-US" sz="600" b="1" dirty="0">
                 <a:solidFill>
-                  <a:srgbClr val="1D6B73"/>
+                  <a:srgbClr val="34494E"/>
                 </a:solidFill>
                 <a:latin typeface="Yu Gothic" pitchFamily="34" charset="0"/>
                 <a:ea typeface="Yu Gothic" pitchFamily="34" charset="-122"/>
@@ -6787,7 +6787,7 @@
           </a:solidFill>
           <a:ln w="25400">
             <a:solidFill>
-              <a:srgbClr val="1D6B73"/>
+              <a:srgbClr val="34494E"/>
             </a:solidFill>
             <a:prstDash val="solid"/>
           </a:ln>
@@ -6823,7 +6823,7 @@
             <a:r>
               <a:rPr lang="en-US" sz="600" b="1" dirty="0">
                 <a:solidFill>
-                  <a:srgbClr val="1D6B73"/>
+                  <a:srgbClr val="34494E"/>
                 </a:solidFill>
                 <a:latin typeface="Yu Gothic" pitchFamily="34" charset="0"/>
                 <a:ea typeface="Yu Gothic" pitchFamily="34" charset="-122"/>
@@ -6843,7 +6843,7 @@
             <a:r>
               <a:rPr lang="en-US" sz="600" b="1" dirty="0">
                 <a:solidFill>
-                  <a:srgbClr val="1D6B73"/>
+                  <a:srgbClr val="34494E"/>
                 </a:solidFill>
                 <a:latin typeface="Yu Gothic" pitchFamily="34" charset="0"/>
                 <a:ea typeface="Yu Gothic" pitchFamily="34" charset="-122"/>
@@ -6874,7 +6874,7 @@
           </a:solidFill>
           <a:ln w="25400">
             <a:solidFill>
-              <a:srgbClr val="1D6B73"/>
+              <a:srgbClr val="34494E"/>
             </a:solidFill>
             <a:prstDash val="solid"/>
           </a:ln>
@@ -6910,7 +6910,7 @@
             <a:r>
               <a:rPr lang="en-US" sz="600" b="1" dirty="0">
                 <a:solidFill>
-                  <a:srgbClr val="1D6B73"/>
+                  <a:srgbClr val="34494E"/>
                 </a:solidFill>
                 <a:latin typeface="Yu Gothic" pitchFamily="34" charset="0"/>
                 <a:ea typeface="Yu Gothic" pitchFamily="34" charset="-122"/>
@@ -6937,7 +6937,7 @@
             <a:avLst/>
           </a:prstGeom>
           <a:solidFill>
-            <a:srgbClr val="E8F3F3"/>
+            <a:srgbClr val="EEF1F0"/>
           </a:solidFill>
           <a:ln/>
         </p:spPr>
@@ -6972,7 +6972,7 @@
             <a:r>
               <a:rPr lang="en-US" sz="740" b="1" dirty="0">
                 <a:solidFill>
-                  <a:srgbClr val="1D6B73"/>
+                  <a:srgbClr val="34494E"/>
                 </a:solidFill>
                 <a:latin typeface="Yu Gothic" pitchFamily="34" charset="0"/>
                 <a:ea typeface="Yu Gothic" pitchFamily="34" charset="-122"/>
@@ -7118,7 +7118,7 @@
             <a:r>
               <a:rPr lang="en-US" sz="740" b="1" dirty="0">
                 <a:solidFill>
-                  <a:srgbClr val="1D6B73"/>
+                  <a:srgbClr val="34494E"/>
                 </a:solidFill>
                 <a:latin typeface="Yu Gothic" pitchFamily="34" charset="0"/>
                 <a:ea typeface="Yu Gothic" pitchFamily="34" charset="-122"/>
@@ -7229,7 +7229,7 @@
             <a:avLst/>
           </a:prstGeom>
           <a:solidFill>
-            <a:srgbClr val="E8F3F3"/>
+            <a:srgbClr val="EEF1F0"/>
           </a:solidFill>
           <a:ln/>
         </p:spPr>
@@ -7264,7 +7264,7 @@
             <a:r>
               <a:rPr lang="en-US" sz="740" b="1" dirty="0">
                 <a:solidFill>
-                  <a:srgbClr val="1D6B73"/>
+                  <a:srgbClr val="34494E"/>
                 </a:solidFill>
                 <a:latin typeface="Yu Gothic" pitchFamily="34" charset="0"/>
                 <a:ea typeface="Yu Gothic" pitchFamily="34" charset="-122"/>
@@ -7410,7 +7410,7 @@
             <a:r>
               <a:rPr lang="en-US" sz="740" b="1" dirty="0">
                 <a:solidFill>
-                  <a:srgbClr val="1D6B73"/>
+                  <a:srgbClr val="34494E"/>
                 </a:solidFill>
                 <a:latin typeface="Yu Gothic" pitchFamily="34" charset="0"/>
                 <a:ea typeface="Yu Gothic" pitchFamily="34" charset="-122"/>
@@ -7521,7 +7521,7 @@
             <a:avLst/>
           </a:prstGeom>
           <a:solidFill>
-            <a:srgbClr val="E8F3F3"/>
+            <a:srgbClr val="EEF1F0"/>
           </a:solidFill>
           <a:ln/>
         </p:spPr>
@@ -7556,7 +7556,7 @@
             <a:r>
               <a:rPr lang="en-US" sz="740" b="1" dirty="0">
                 <a:solidFill>
-                  <a:srgbClr val="1D6B73"/>
+                  <a:srgbClr val="34494E"/>
                 </a:solidFill>
                 <a:latin typeface="Yu Gothic" pitchFamily="34" charset="0"/>
                 <a:ea typeface="Yu Gothic" pitchFamily="34" charset="-122"/>
@@ -7858,7 +7858,7 @@
             <a:avLst/>
           </a:prstGeom>
           <a:solidFill>
-            <a:srgbClr val="1D6B73"/>
+            <a:srgbClr val="34494E"/>
           </a:solidFill>
           <a:ln/>
         </p:spPr>
@@ -7899,7 +7899,7 @@
             <a:avLst/>
           </a:prstGeom>
           <a:solidFill>
-            <a:srgbClr val="D08A1E"/>
+            <a:srgbClr val="A88A5C"/>
           </a:solidFill>
           <a:ln/>
         </p:spPr>
@@ -7940,7 +7940,7 @@
             <a:avLst/>
           </a:prstGeom>
           <a:solidFill>
-            <a:srgbClr val="1D6B73"/>
+            <a:srgbClr val="34494E"/>
           </a:solidFill>
           <a:ln/>
         </p:spPr>
@@ -7981,7 +7981,7 @@
             <a:avLst/>
           </a:prstGeom>
           <a:solidFill>
-            <a:srgbClr val="D08A1E"/>
+            <a:srgbClr val="A88A5C"/>
           </a:solidFill>
           <a:ln/>
         </p:spPr>
@@ -8022,7 +8022,7 @@
             <a:avLst/>
           </a:prstGeom>
           <a:solidFill>
-            <a:srgbClr val="1D6B73"/>
+            <a:srgbClr val="34494E"/>
           </a:solidFill>
           <a:ln/>
         </p:spPr>
@@ -8105,11 +8105,11 @@
             <a:avLst/>
           </a:prstGeom>
           <a:solidFill>
-            <a:srgbClr val="E8F3F3"/>
+            <a:srgbClr val="EEF1F0"/>
           </a:solidFill>
           <a:ln w="12700">
             <a:solidFill>
-              <a:srgbClr val="B7D6D6"/>
+              <a:srgbClr val="CBD3D1"/>
             </a:solidFill>
             <a:prstDash val="solid"/>
           </a:ln>
@@ -8167,7 +8167,7 @@
             <a:r>
               <a:rPr lang="en-US" sz="560" dirty="0">
                 <a:solidFill>
-                  <a:srgbClr val="1D6B73"/>
+                  <a:srgbClr val="34494E"/>
                 </a:solidFill>
                 <a:latin typeface="Yu Gothic" pitchFamily="34" charset="0"/>
                 <a:ea typeface="Yu Gothic" pitchFamily="34" charset="-122"/>
@@ -8218,11 +8218,11 @@
             <a:avLst/>
           </a:prstGeom>
           <a:solidFill>
-            <a:srgbClr val="E8F3F3"/>
+            <a:srgbClr val="EEF1F0"/>
           </a:solidFill>
           <a:ln w="12700">
             <a:solidFill>
-              <a:srgbClr val="B7D6D6"/>
+              <a:srgbClr val="CBD3D1"/>
             </a:solidFill>
             <a:prstDash val="solid"/>
           </a:ln>
@@ -8515,11 +8515,11 @@
             <a:avLst/>
           </a:prstGeom>
           <a:solidFill>
-            <a:srgbClr val="E8F3F3"/>
+            <a:srgbClr val="EEF1F0"/>
           </a:solidFill>
           <a:ln w="12700">
             <a:solidFill>
-              <a:srgbClr val="B7D6D6"/>
+              <a:srgbClr val="CBD3D1"/>
             </a:solidFill>
             <a:prstDash val="solid"/>
           </a:ln>
@@ -8577,7 +8577,7 @@
             <a:r>
               <a:rPr lang="en-US" sz="560" dirty="0">
                 <a:solidFill>
-                  <a:srgbClr val="1D6B73"/>
+                  <a:srgbClr val="34494E"/>
                 </a:solidFill>
                 <a:latin typeface="Yu Gothic" pitchFamily="34" charset="0"/>
                 <a:ea typeface="Yu Gothic" pitchFamily="34" charset="-122"/>
@@ -8628,11 +8628,11 @@
             <a:avLst/>
           </a:prstGeom>
           <a:solidFill>
-            <a:srgbClr val="E8F3F3"/>
+            <a:srgbClr val="EEF1F0"/>
           </a:solidFill>
           <a:ln w="12700">
             <a:solidFill>
-              <a:srgbClr val="B7D6D6"/>
+              <a:srgbClr val="CBD3D1"/>
             </a:solidFill>
             <a:prstDash val="solid"/>
           </a:ln>
@@ -8690,7 +8690,7 @@
             <a:r>
               <a:rPr lang="en-US" sz="560" dirty="0">
                 <a:solidFill>
-                  <a:srgbClr val="1D6B73"/>
+                  <a:srgbClr val="34494E"/>
                 </a:solidFill>
                 <a:latin typeface="Yu Gothic" pitchFamily="34" charset="0"/>
                 <a:ea typeface="Yu Gothic" pitchFamily="34" charset="-122"/>
@@ -8741,11 +8741,11 @@
             <a:avLst/>
           </a:prstGeom>
           <a:solidFill>
-            <a:srgbClr val="FBF0DD"/>
+            <a:srgbClr val="F5F0E8"/>
           </a:solidFill>
           <a:ln w="12700">
             <a:solidFill>
-              <a:srgbClr val="D08A1E"/>
+              <a:srgbClr val="A88A5C"/>
             </a:solidFill>
             <a:prstDash val="solid"/>
           </a:ln>
@@ -8903,11 +8903,11 @@
             <a:avLst/>
           </a:prstGeom>
           <a:solidFill>
-            <a:srgbClr val="FBF0DD"/>
+            <a:srgbClr val="F5F0E8"/>
           </a:solidFill>
           <a:ln w="12700">
             <a:solidFill>
-              <a:srgbClr val="D08A1E"/>
+              <a:srgbClr val="A88A5C"/>
             </a:solidFill>
             <a:prstDash val="solid"/>
           </a:ln>
@@ -9018,7 +9018,7 @@
           <a:noFill/>
           <a:ln w="25400">
             <a:solidFill>
-              <a:srgbClr val="1D6B73"/>
+              <a:srgbClr val="34494E"/>
             </a:solidFill>
             <a:prstDash val="solid"/>
           </a:ln>
@@ -9083,7 +9083,7 @@
           <a:noFill/>
           <a:ln w="25400">
             <a:solidFill>
-              <a:srgbClr val="D08A1E"/>
+              <a:srgbClr val="A88A5C"/>
             </a:solidFill>
             <a:prstDash val="solid"/>
           </a:ln>
@@ -9208,7 +9208,7 @@
             <a:avLst/>
           </a:prstGeom>
           <a:solidFill>
-            <a:srgbClr val="1D6B73"/>
+            <a:srgbClr val="34494E"/>
           </a:solidFill>
           <a:ln/>
         </p:spPr>
@@ -9314,7 +9314,7 @@
             <a:avLst/>
           </a:prstGeom>
           <a:solidFill>
-            <a:srgbClr val="1D6B73"/>
+            <a:srgbClr val="34494E"/>
           </a:solidFill>
           <a:ln/>
         </p:spPr>
@@ -9420,7 +9420,7 @@
             <a:avLst/>
           </a:prstGeom>
           <a:solidFill>
-            <a:srgbClr val="D08A1E"/>
+            <a:srgbClr val="A88A5C"/>
           </a:solidFill>
           <a:ln/>
         </p:spPr>
@@ -9526,7 +9526,7 @@
             <a:avLst/>
           </a:prstGeom>
           <a:solidFill>
-            <a:srgbClr val="1D6B73"/>
+            <a:srgbClr val="34494E"/>
           </a:solidFill>
           <a:ln/>
         </p:spPr>
@@ -9752,7 +9752,7 @@
         <p:spPr>
           <a:xfrm>
             <a:off x="3810000" y="10261600"/>
-            <a:ext cx="6180534" cy="152400"/>
+            <a:ext cx="5549900" cy="152400"/>
           </a:xfrm>
           <a:prstGeom prst="rect">
             <a:avLst/>
@@ -9778,7 +9778,7 @@
                 <a:ea typeface="Yu Gothic" pitchFamily="34" charset="-122"/>
                 <a:cs typeface="Yu Gothic" pitchFamily="34" charset="-120"/>
               </a:rPr>
-              <a:t>台割 完成版（構成確認用・PwC様レビュー10/2反映）— 青ラベル＝改善点／色は台割用（緑＝資源投資・橙＝トレーディング）で表紙3案とは無関係</a:t>
+              <a:t>台割 完成版（構成確認用・PwC様レビュー10/2反映）— 色は台割用（深緑＝資源投資・黄土＝トレーディング）で表紙3案とは無関係</a:t>
             </a:r>
             <a:endParaRPr lang="en-US" sz="660" dirty="0"/>
           </a:p>
@@ -10126,7 +10126,7 @@
             <a:avLst/>
           </a:prstGeom>
           <a:solidFill>
-            <a:srgbClr val="3D3F42"/>
+            <a:srgbClr val="4A4C4F"/>
           </a:solidFill>
           <a:ln/>
         </p:spPr>
@@ -10196,7 +10196,7 @@
             <a:r>
               <a:rPr lang="en-US" sz="640" b="1" spc="80" kern="0" dirty="0">
                 <a:solidFill>
-                  <a:srgbClr val="3D3F42"/>
+                  <a:srgbClr val="4A4C4F"/>
                 </a:solidFill>
                 <a:latin typeface="Yu Gothic" pitchFamily="34" charset="0"/>
                 <a:ea typeface="Yu Gothic" pitchFamily="34" charset="-122"/>
@@ -10238,7 +10238,7 @@
             <a:r>
               <a:rPr lang="en-US" sz="1100" b="1" dirty="0">
                 <a:solidFill>
-                  <a:srgbClr val="3D3F42"/>
+                  <a:srgbClr val="4A4C4F"/>
                 </a:solidFill>
                 <a:latin typeface="Yu Gothic" pitchFamily="34" charset="0"/>
                 <a:ea typeface="Yu Gothic" pitchFamily="34" charset="-122"/>
@@ -10322,7 +10322,7 @@
             <a:r>
               <a:rPr lang="en-US" sz="640" b="1" spc="80" kern="0" dirty="0">
                 <a:solidFill>
-                  <a:srgbClr val="3D3F42"/>
+                  <a:srgbClr val="4A4C4F"/>
                 </a:solidFill>
                 <a:latin typeface="Yu Gothic" pitchFamily="34" charset="0"/>
                 <a:ea typeface="Yu Gothic" pitchFamily="34" charset="-122"/>
@@ -10364,7 +10364,7 @@
             <a:r>
               <a:rPr lang="en-US" sz="1100" b="1" dirty="0">
                 <a:solidFill>
-                  <a:srgbClr val="3D3F42"/>
+                  <a:srgbClr val="4A4C4F"/>
                 </a:solidFill>
                 <a:latin typeface="Yu Gothic" pitchFamily="34" charset="0"/>
                 <a:ea typeface="Yu Gothic" pitchFamily="34" charset="-122"/>
@@ -10448,7 +10448,7 @@
             <a:r>
               <a:rPr lang="en-US" sz="640" b="1" spc="80" kern="0" dirty="0">
                 <a:solidFill>
-                  <a:srgbClr val="3D3F42"/>
+                  <a:srgbClr val="4A4C4F"/>
                 </a:solidFill>
                 <a:latin typeface="Yu Gothic" pitchFamily="34" charset="0"/>
                 <a:ea typeface="Yu Gothic" pitchFamily="34" charset="-122"/>
@@ -10490,7 +10490,7 @@
             <a:r>
               <a:rPr lang="en-US" sz="1100" b="1" dirty="0">
                 <a:solidFill>
-                  <a:srgbClr val="3D3F42"/>
+                  <a:srgbClr val="4A4C4F"/>
                 </a:solidFill>
                 <a:latin typeface="Yu Gothic" pitchFamily="34" charset="0"/>
                 <a:ea typeface="Yu Gothic" pitchFamily="34" charset="-122"/>
@@ -10559,7 +10559,7 @@
             <a:avLst/>
           </a:prstGeom>
           <a:solidFill>
-            <a:srgbClr val="F7EBE2"/>
+            <a:srgbClr val="F4EEEA"/>
           </a:solidFill>
           <a:ln/>
         </p:spPr>
@@ -10579,7 +10579,7 @@
             <a:avLst/>
           </a:prstGeom>
           <a:solidFill>
-            <a:srgbClr val="B8693A"/>
+            <a:srgbClr val="9C7360"/>
           </a:solidFill>
           <a:ln/>
         </p:spPr>
@@ -10649,7 +10649,7 @@
             <a:r>
               <a:rPr lang="en-US" sz="640" b="1" spc="80" kern="0" dirty="0">
                 <a:solidFill>
-                  <a:srgbClr val="B8693A"/>
+                  <a:srgbClr val="9C7360"/>
                 </a:solidFill>
                 <a:latin typeface="Yu Gothic" pitchFamily="34" charset="0"/>
                 <a:ea typeface="Yu Gothic" pitchFamily="34" charset="-122"/>
@@ -10691,7 +10691,7 @@
             <a:r>
               <a:rPr lang="en-US" sz="1100" b="1" dirty="0">
                 <a:solidFill>
-                  <a:srgbClr val="B8693A"/>
+                  <a:srgbClr val="9C7360"/>
                 </a:solidFill>
                 <a:latin typeface="Yu Gothic" pitchFamily="34" charset="0"/>
                 <a:ea typeface="Yu Gothic" pitchFamily="34" charset="-122"/>
@@ -10775,7 +10775,7 @@
             <a:r>
               <a:rPr lang="en-US" sz="640" b="1" spc="80" kern="0" dirty="0">
                 <a:solidFill>
-                  <a:srgbClr val="B8693A"/>
+                  <a:srgbClr val="9C7360"/>
                 </a:solidFill>
                 <a:latin typeface="Yu Gothic" pitchFamily="34" charset="0"/>
                 <a:ea typeface="Yu Gothic" pitchFamily="34" charset="-122"/>
@@ -10817,7 +10817,7 @@
             <a:r>
               <a:rPr lang="en-US" sz="1100" b="1" dirty="0">
                 <a:solidFill>
-                  <a:srgbClr val="B8693A"/>
+                  <a:srgbClr val="9C7360"/>
                 </a:solidFill>
                 <a:latin typeface="Yu Gothic" pitchFamily="34" charset="0"/>
                 <a:ea typeface="Yu Gothic" pitchFamily="34" charset="-122"/>
@@ -10901,7 +10901,7 @@
             <a:r>
               <a:rPr lang="en-US" sz="640" b="1" spc="80" kern="0" dirty="0">
                 <a:solidFill>
-                  <a:srgbClr val="B8693A"/>
+                  <a:srgbClr val="9C7360"/>
                 </a:solidFill>
                 <a:latin typeface="Yu Gothic" pitchFamily="34" charset="0"/>
                 <a:ea typeface="Yu Gothic" pitchFamily="34" charset="-122"/>
@@ -10943,7 +10943,7 @@
             <a:r>
               <a:rPr lang="en-US" sz="1100" b="1" dirty="0">
                 <a:solidFill>
-                  <a:srgbClr val="B8693A"/>
+                  <a:srgbClr val="9C7360"/>
                 </a:solidFill>
                 <a:latin typeface="Yu Gothic" pitchFamily="34" charset="0"/>
                 <a:ea typeface="Yu Gothic" pitchFamily="34" charset="-122"/>
@@ -11245,7 +11245,7 @@
             <a:avLst/>
           </a:prstGeom>
           <a:solidFill>
-            <a:srgbClr val="E8F3F3"/>
+            <a:srgbClr val="EEF1F0"/>
           </a:solidFill>
           <a:ln/>
         </p:spPr>
@@ -11311,7 +11311,7 @@
             </a:avLst>
           </a:prstGeom>
           <a:solidFill>
-            <a:srgbClr val="1D6B73"/>
+            <a:srgbClr val="34494E"/>
           </a:solidFill>
           <a:ln/>
         </p:spPr>
@@ -11394,7 +11394,7 @@
             <a:avLst/>
           </a:prstGeom>
           <a:solidFill>
-            <a:srgbClr val="E8F3F3"/>
+            <a:srgbClr val="EEF1F0"/>
           </a:solidFill>
           <a:ln/>
         </p:spPr>
@@ -11460,7 +11460,7 @@
             </a:avLst>
           </a:prstGeom>
           <a:solidFill>
-            <a:srgbClr val="1D6B73"/>
+            <a:srgbClr val="34494E"/>
           </a:solidFill>
           <a:ln/>
         </p:spPr>
@@ -11543,7 +11543,7 @@
             <a:avLst/>
           </a:prstGeom>
           <a:solidFill>
-            <a:srgbClr val="E8F3F3"/>
+            <a:srgbClr val="EEF1F0"/>
           </a:solidFill>
           <a:ln/>
         </p:spPr>
@@ -11609,7 +11609,7 @@
             </a:avLst>
           </a:prstGeom>
           <a:solidFill>
-            <a:srgbClr val="1D6B73"/>
+            <a:srgbClr val="34494E"/>
           </a:solidFill>
           <a:ln/>
         </p:spPr>
@@ -11692,7 +11692,7 @@
             <a:avLst/>
           </a:prstGeom>
           <a:solidFill>
-            <a:srgbClr val="E8F3F3"/>
+            <a:srgbClr val="EEF1F0"/>
           </a:solidFill>
           <a:ln/>
         </p:spPr>
@@ -11758,7 +11758,7 @@
             </a:avLst>
           </a:prstGeom>
           <a:solidFill>
-            <a:srgbClr val="1D6B73"/>
+            <a:srgbClr val="34494E"/>
           </a:solidFill>
           <a:ln/>
         </p:spPr>
@@ -12075,7 +12075,7 @@
             <a:avLst/>
           </a:prstGeom>
           <a:solidFill>
-            <a:srgbClr val="1D6B73"/>
+            <a:srgbClr val="34494E"/>
           </a:solidFill>
           <a:ln/>
         </p:spPr>
@@ -12181,11 +12181,11 @@
             <a:avLst/>
           </a:prstGeom>
           <a:solidFill>
-            <a:srgbClr val="E8F3F3"/>
+            <a:srgbClr val="EEF1F0"/>
           </a:solidFill>
           <a:ln w="12700">
             <a:solidFill>
-              <a:srgbClr val="1D6B73"/>
+              <a:srgbClr val="34494E"/>
             </a:solidFill>
             <a:prstDash val="solid"/>
           </a:ln>
@@ -12403,7 +12403,7 @@
             <a:avLst/>
           </a:prstGeom>
           <a:solidFill>
-            <a:srgbClr val="3D3F42"/>
+            <a:srgbClr val="4A4C4F"/>
           </a:solidFill>
           <a:ln/>
         </p:spPr>
@@ -12467,7 +12467,7 @@
             <a:avLst/>
           </a:prstGeom>
           <a:solidFill>
-            <a:srgbClr val="1D6B73"/>
+            <a:srgbClr val="34494E"/>
           </a:solidFill>
           <a:ln/>
         </p:spPr>
@@ -12550,7 +12550,7 @@
             <a:avLst/>
           </a:prstGeom>
           <a:solidFill>
-            <a:srgbClr val="1D6B73"/>
+            <a:srgbClr val="34494E"/>
           </a:solidFill>
           <a:ln/>
         </p:spPr>
@@ -12633,7 +12633,7 @@
             <a:avLst/>
           </a:prstGeom>
           <a:solidFill>
-            <a:srgbClr val="1D6B73"/>
+            <a:srgbClr val="34494E"/>
           </a:solidFill>
           <a:ln/>
         </p:spPr>
@@ -12716,7 +12716,7 @@
             <a:avLst/>
           </a:prstGeom>
           <a:solidFill>
-            <a:srgbClr val="1D6B73"/>
+            <a:srgbClr val="34494E"/>
           </a:solidFill>
           <a:ln/>
         </p:spPr>
@@ -12799,7 +12799,7 @@
             <a:avLst/>
           </a:prstGeom>
           <a:solidFill>
-            <a:srgbClr val="1D6B73"/>
+            <a:srgbClr val="34494E"/>
           </a:solidFill>
           <a:ln/>
         </p:spPr>
@@ -14084,7 +14084,7 @@
             <a:avLst/>
           </a:prstGeom>
           <a:solidFill>
-            <a:srgbClr val="B8693A"/>
+            <a:srgbClr val="9C7360"/>
           </a:solidFill>
           <a:ln/>
         </p:spPr>
@@ -14125,7 +14125,7 @@
             <a:avLst/>
           </a:prstGeom>
           <a:solidFill>
-            <a:srgbClr val="B8693A"/>
+            <a:srgbClr val="9C7360"/>
           </a:solidFill>
           <a:ln/>
         </p:spPr>
@@ -14166,7 +14166,7 @@
             <a:avLst/>
           </a:prstGeom>
           <a:solidFill>
-            <a:srgbClr val="B8693A"/>
+            <a:srgbClr val="9C7360"/>
           </a:solidFill>
           <a:ln/>
         </p:spPr>
@@ -14207,7 +14207,7 @@
             <a:avLst/>
           </a:prstGeom>
           <a:solidFill>
-            <a:srgbClr val="B8693A"/>
+            <a:srgbClr val="9C7360"/>
           </a:solidFill>
           <a:ln/>
         </p:spPr>
@@ -14248,7 +14248,7 @@
             <a:avLst/>
           </a:prstGeom>
           <a:solidFill>
-            <a:srgbClr val="B8693A"/>
+            <a:srgbClr val="9C7360"/>
           </a:solidFill>
           <a:ln/>
         </p:spPr>
@@ -14289,7 +14289,7 @@
             <a:avLst/>
           </a:prstGeom>
           <a:solidFill>
-            <a:srgbClr val="F7EBE2"/>
+            <a:srgbClr val="F4EEEA"/>
           </a:solidFill>
           <a:ln/>
         </p:spPr>
@@ -14333,7 +14333,7 @@
             <a:avLst/>
           </a:prstGeom>
           <a:solidFill>
-            <a:srgbClr val="F7EBE2"/>
+            <a:srgbClr val="F4EEEA"/>
           </a:solidFill>
           <a:ln/>
         </p:spPr>
@@ -14377,7 +14377,7 @@
             <a:avLst/>
           </a:prstGeom>
           <a:solidFill>
-            <a:srgbClr val="F7EBE2"/>
+            <a:srgbClr val="F4EEEA"/>
           </a:solidFill>
           <a:ln/>
         </p:spPr>
@@ -14421,7 +14421,7 @@
             <a:avLst/>
           </a:prstGeom>
           <a:solidFill>
-            <a:srgbClr val="F7EBE2"/>
+            <a:srgbClr val="F4EEEA"/>
           </a:solidFill>
           <a:ln/>
         </p:spPr>
@@ -14465,7 +14465,7 @@
             <a:avLst/>
           </a:prstGeom>
           <a:solidFill>
-            <a:srgbClr val="F7EBE2"/>
+            <a:srgbClr val="F4EEEA"/>
           </a:solidFill>
           <a:ln/>
         </p:spPr>
@@ -14719,7 +14719,7 @@
             <a:avLst/>
           </a:prstGeom>
           <a:solidFill>
-            <a:srgbClr val="F7EBE2"/>
+            <a:srgbClr val="F4EEEA"/>
           </a:solidFill>
           <a:ln/>
         </p:spPr>
@@ -14763,7 +14763,7 @@
             <a:avLst/>
           </a:prstGeom>
           <a:solidFill>
-            <a:srgbClr val="F7EBE2"/>
+            <a:srgbClr val="F4EEEA"/>
           </a:solidFill>
           <a:ln/>
         </p:spPr>
@@ -14807,7 +14807,7 @@
             <a:avLst/>
           </a:prstGeom>
           <a:solidFill>
-            <a:srgbClr val="F7EBE2"/>
+            <a:srgbClr val="F4EEEA"/>
           </a:solidFill>
           <a:ln/>
         </p:spPr>
@@ -14851,7 +14851,7 @@
             <a:avLst/>
           </a:prstGeom>
           <a:solidFill>
-            <a:srgbClr val="F7EBE2"/>
+            <a:srgbClr val="F4EEEA"/>
           </a:solidFill>
           <a:ln/>
         </p:spPr>
@@ -14895,7 +14895,7 @@
             <a:avLst/>
           </a:prstGeom>
           <a:solidFill>
-            <a:srgbClr val="F7EBE2"/>
+            <a:srgbClr val="F4EEEA"/>
           </a:solidFill>
           <a:ln/>
         </p:spPr>
@@ -15149,7 +15149,7 @@
             <a:avLst/>
           </a:prstGeom>
           <a:solidFill>
-            <a:srgbClr val="F7EBE2"/>
+            <a:srgbClr val="F4EEEA"/>
           </a:solidFill>
           <a:ln/>
         </p:spPr>
@@ -15193,7 +15193,7 @@
             <a:avLst/>
           </a:prstGeom>
           <a:solidFill>
-            <a:srgbClr val="F7EBE2"/>
+            <a:srgbClr val="F4EEEA"/>
           </a:solidFill>
           <a:ln/>
         </p:spPr>
@@ -15237,7 +15237,7 @@
             <a:avLst/>
           </a:prstGeom>
           <a:solidFill>
-            <a:srgbClr val="F7EBE2"/>
+            <a:srgbClr val="F4EEEA"/>
           </a:solidFill>
           <a:ln/>
         </p:spPr>
@@ -15281,7 +15281,7 @@
             <a:avLst/>
           </a:prstGeom>
           <a:solidFill>
-            <a:srgbClr val="F7EBE2"/>
+            <a:srgbClr val="F4EEEA"/>
           </a:solidFill>
           <a:ln/>
         </p:spPr>
@@ -15325,7 +15325,7 @@
             <a:avLst/>
           </a:prstGeom>
           <a:solidFill>
-            <a:srgbClr val="F7EBE2"/>
+            <a:srgbClr val="F4EEEA"/>
           </a:solidFill>
           <a:ln/>
         </p:spPr>
@@ -15579,7 +15579,7 @@
             <a:avLst/>
           </a:prstGeom>
           <a:solidFill>
-            <a:srgbClr val="F7EBE2"/>
+            <a:srgbClr val="F4EEEA"/>
           </a:solidFill>
           <a:ln/>
         </p:spPr>
@@ -15623,7 +15623,7 @@
             <a:avLst/>
           </a:prstGeom>
           <a:solidFill>
-            <a:srgbClr val="F7EBE2"/>
+            <a:srgbClr val="F4EEEA"/>
           </a:solidFill>
           <a:ln/>
         </p:spPr>
@@ -15667,7 +15667,7 @@
             <a:avLst/>
           </a:prstGeom>
           <a:solidFill>
-            <a:srgbClr val="F7EBE2"/>
+            <a:srgbClr val="F4EEEA"/>
           </a:solidFill>
           <a:ln/>
         </p:spPr>
@@ -15711,7 +15711,7 @@
             <a:avLst/>
           </a:prstGeom>
           <a:solidFill>
-            <a:srgbClr val="F7EBE2"/>
+            <a:srgbClr val="F4EEEA"/>
           </a:solidFill>
           <a:ln/>
         </p:spPr>
@@ -15755,7 +15755,7 @@
             <a:avLst/>
           </a:prstGeom>
           <a:solidFill>
-            <a:srgbClr val="F7EBE2"/>
+            <a:srgbClr val="F4EEEA"/>
           </a:solidFill>
           <a:ln/>
         </p:spPr>
@@ -15967,7 +15967,7 @@
             <a:avLst/>
           </a:prstGeom>
           <a:solidFill>
-            <a:srgbClr val="CDD5D8"/>
+            <a:srgbClr val="D9DCDC"/>
           </a:solidFill>
           <a:ln/>
         </p:spPr>
@@ -16113,7 +16113,7 @@
             <a:avLst/>
           </a:prstGeom>
           <a:solidFill>
-            <a:srgbClr val="CDD5D8"/>
+            <a:srgbClr val="D9DCDC"/>
           </a:solidFill>
           <a:ln/>
         </p:spPr>
@@ -16259,7 +16259,7 @@
             <a:avLst/>
           </a:prstGeom>
           <a:solidFill>
-            <a:srgbClr val="CDD5D8"/>
+            <a:srgbClr val="D9DCDC"/>
           </a:solidFill>
           <a:ln/>
         </p:spPr>
@@ -16405,7 +16405,7 @@
             <a:avLst/>
           </a:prstGeom>
           <a:solidFill>
-            <a:srgbClr val="CDD5D8"/>
+            <a:srgbClr val="D9DCDC"/>
           </a:solidFill>
           <a:ln/>
         </p:spPr>
@@ -16551,7 +16551,7 @@
             <a:avLst/>
           </a:prstGeom>
           <a:solidFill>
-            <a:srgbClr val="CDD5D8"/>
+            <a:srgbClr val="D9DCDC"/>
           </a:solidFill>
           <a:ln/>
         </p:spPr>
@@ -16697,7 +16697,7 @@
             <a:avLst/>
           </a:prstGeom>
           <a:solidFill>
-            <a:srgbClr val="CDD5D8"/>
+            <a:srgbClr val="D9DCDC"/>
           </a:solidFill>
           <a:ln/>
         </p:spPr>
@@ -16843,7 +16843,7 @@
             <a:avLst/>
           </a:prstGeom>
           <a:solidFill>
-            <a:srgbClr val="CDD5D8"/>
+            <a:srgbClr val="D9DCDC"/>
           </a:solidFill>
           <a:ln/>
         </p:spPr>
@@ -16989,7 +16989,7 @@
             <a:avLst/>
           </a:prstGeom>
           <a:solidFill>
-            <a:srgbClr val="CDD5D8"/>
+            <a:srgbClr val="D9DCDC"/>
           </a:solidFill>
           <a:ln/>
         </p:spPr>
@@ -17135,7 +17135,7 @@
             <a:avLst/>
           </a:prstGeom>
           <a:solidFill>
-            <a:srgbClr val="CDD5D8"/>
+            <a:srgbClr val="D9DCDC"/>
           </a:solidFill>
           <a:ln/>
         </p:spPr>
@@ -17281,7 +17281,7 @@
             <a:avLst/>
           </a:prstGeom>
           <a:solidFill>
-            <a:srgbClr val="CDD5D8"/>
+            <a:srgbClr val="D9DCDC"/>
           </a:solidFill>
           <a:ln/>
         </p:spPr>
@@ -17427,7 +17427,7 @@
             <a:avLst/>
           </a:prstGeom>
           <a:solidFill>
-            <a:srgbClr val="CDD5D8"/>
+            <a:srgbClr val="D9DCDC"/>
           </a:solidFill>
           <a:ln/>
         </p:spPr>
@@ -17573,7 +17573,7 @@
             <a:avLst/>
           </a:prstGeom>
           <a:solidFill>
-            <a:srgbClr val="CDD5D8"/>
+            <a:srgbClr val="D9DCDC"/>
           </a:solidFill>
           <a:ln/>
         </p:spPr>
@@ -17719,7 +17719,7 @@
             <a:avLst/>
           </a:prstGeom>
           <a:solidFill>
-            <a:srgbClr val="B8693A"/>
+            <a:srgbClr val="9C7360"/>
           </a:solidFill>
           <a:ln/>
         </p:spPr>
@@ -17781,7 +17781,7 @@
             <a:avLst/>
           </a:prstGeom>
           <a:solidFill>
-            <a:srgbClr val="B8693A"/>
+            <a:srgbClr val="9C7360"/>
           </a:solidFill>
           <a:ln/>
         </p:spPr>
@@ -17984,7 +17984,7 @@
         <p:spPr>
           <a:xfrm>
             <a:off x="3810000" y="10261600"/>
-            <a:ext cx="6180534" cy="152400"/>
+            <a:ext cx="5549900" cy="152400"/>
           </a:xfrm>
           <a:prstGeom prst="rect">
             <a:avLst/>
@@ -18010,7 +18010,7 @@
                 <a:ea typeface="Yu Gothic" pitchFamily="34" charset="-122"/>
                 <a:cs typeface="Yu Gothic" pitchFamily="34" charset="-120"/>
               </a:rPr>
-              <a:t>台割 完成版（構成確認用・PwC様レビュー10/2反映）— 青ラベル＝改善点／色は台割用（緑＝資源投資・橙＝トレーディング）で表紙3案とは無関係</a:t>
+              <a:t>台割 完成版（構成確認用・PwC様レビュー10/2反映）— 色は台割用（深緑＝資源投資・黄土＝トレーディング）で表紙3案とは無関係</a:t>
             </a:r>
             <a:endParaRPr lang="en-US" sz="660" dirty="0"/>
           </a:p>
@@ -18659,7 +18659,7 @@
             </a:avLst>
           </a:prstGeom>
           <a:solidFill>
-            <a:srgbClr val="D08A1E"/>
+            <a:srgbClr val="A88A5C"/>
           </a:solidFill>
           <a:ln/>
         </p:spPr>
@@ -18723,11 +18723,11 @@
             <a:avLst/>
           </a:prstGeom>
           <a:solidFill>
-            <a:srgbClr val="E8F3F3"/>
+            <a:srgbClr val="EEF1F0"/>
           </a:solidFill>
           <a:ln w="12700">
             <a:solidFill>
-              <a:srgbClr val="1D6B73"/>
+              <a:srgbClr val="34494E"/>
             </a:solidFill>
             <a:prstDash val="solid"/>
           </a:ln>
@@ -18792,11 +18792,11 @@
             <a:avLst/>
           </a:prstGeom>
           <a:solidFill>
-            <a:srgbClr val="E8F3F3"/>
+            <a:srgbClr val="EEF1F0"/>
           </a:solidFill>
           <a:ln w="12700">
             <a:solidFill>
-              <a:srgbClr val="1D6B73"/>
+              <a:srgbClr val="34494E"/>
             </a:solidFill>
             <a:prstDash val="solid"/>
           </a:ln>
@@ -18861,11 +18861,11 @@
             <a:avLst/>
           </a:prstGeom>
           <a:solidFill>
-            <a:srgbClr val="E8F3F3"/>
+            <a:srgbClr val="EEF1F0"/>
           </a:solidFill>
           <a:ln w="12700">
             <a:solidFill>
-              <a:srgbClr val="1D6B73"/>
+              <a:srgbClr val="34494E"/>
             </a:solidFill>
             <a:prstDash val="solid"/>
           </a:ln>
@@ -18930,11 +18930,11 @@
             <a:avLst/>
           </a:prstGeom>
           <a:solidFill>
-            <a:srgbClr val="E8F3F3"/>
+            <a:srgbClr val="EEF1F0"/>
           </a:solidFill>
           <a:ln w="12700">
             <a:solidFill>
-              <a:srgbClr val="1D6B73"/>
+              <a:srgbClr val="34494E"/>
             </a:solidFill>
             <a:prstDash val="solid"/>
           </a:ln>
@@ -19416,7 +19416,7 @@
             <a:r>
               <a:rPr lang="en-US" sz="640" b="1" dirty="0">
                 <a:solidFill>
-                  <a:srgbClr val="1D6B73"/>
+                  <a:srgbClr val="34494E"/>
                 </a:solidFill>
                 <a:latin typeface="Yu Gothic" pitchFamily="34" charset="0"/>
                 <a:ea typeface="Yu Gothic" pitchFamily="34" charset="-122"/>
@@ -19458,7 +19458,7 @@
             <a:r>
               <a:rPr lang="en-US" sz="640" b="1" dirty="0">
                 <a:solidFill>
-                  <a:srgbClr val="D08A1E"/>
+                  <a:srgbClr val="A88A5C"/>
                 </a:solidFill>
                 <a:latin typeface="Yu Gothic" pitchFamily="34" charset="0"/>
                 <a:ea typeface="Yu Gothic" pitchFamily="34" charset="-122"/>
@@ -19635,7 +19635,7 @@
             <a:avLst/>
           </a:prstGeom>
           <a:solidFill>
-            <a:srgbClr val="FBF0DD"/>
+            <a:srgbClr val="F5F0E8"/>
           </a:solidFill>
           <a:ln/>
         </p:spPr>
@@ -19742,7 +19742,7 @@
             <a:avLst/>
           </a:prstGeom>
           <a:solidFill>
-            <a:srgbClr val="FBF0DD"/>
+            <a:srgbClr val="F5F0E8"/>
           </a:solidFill>
           <a:ln/>
         </p:spPr>
@@ -19849,7 +19849,7 @@
             <a:avLst/>
           </a:prstGeom>
           <a:solidFill>
-            <a:srgbClr val="FBF0DD"/>
+            <a:srgbClr val="F5F0E8"/>
           </a:solidFill>
           <a:ln/>
         </p:spPr>
@@ -19956,7 +19956,7 @@
             <a:avLst/>
           </a:prstGeom>
           <a:solidFill>
-            <a:srgbClr val="FBF0DD"/>
+            <a:srgbClr val="F5F0E8"/>
           </a:solidFill>
           <a:ln/>
         </p:spPr>
@@ -20081,7 +20081,7 @@
             <a:avLst/>
           </a:prstGeom>
           <a:solidFill>
-            <a:srgbClr val="1D6B73"/>
+            <a:srgbClr val="34494E"/>
           </a:solidFill>
           <a:ln/>
         </p:spPr>
@@ -20187,7 +20187,7 @@
             <a:avLst/>
           </a:prstGeom>
           <a:solidFill>
-            <a:srgbClr val="D08A1E"/>
+            <a:srgbClr val="A88A5C"/>
           </a:solidFill>
           <a:ln/>
         </p:spPr>
@@ -20359,7 +20359,7 @@
           <a:noFill/>
           <a:ln w="12700">
             <a:solidFill>
-              <a:srgbClr val="1D6B73"/>
+              <a:srgbClr val="34494E"/>
             </a:solidFill>
             <a:prstDash val="dash"/>
           </a:ln>
@@ -20395,7 +20395,7 @@
             <a:r>
               <a:rPr lang="en-US" sz="680" b="1" dirty="0">
                 <a:solidFill>
-                  <a:srgbClr val="1D6B73"/>
+                  <a:srgbClr val="34494E"/>
                 </a:solidFill>
                 <a:latin typeface="Yu Gothic" pitchFamily="34" charset="0"/>
                 <a:ea typeface="Yu Gothic" pitchFamily="34" charset="-122"/>
@@ -20899,7 +20899,7 @@
             <a:avLst/>
           </a:prstGeom>
           <a:solidFill>
-            <a:srgbClr val="F2F7F8"/>
+            <a:srgbClr val="F7F8F7"/>
           </a:solidFill>
           <a:ln/>
         </p:spPr>
@@ -20943,7 +20943,7 @@
             <a:avLst/>
           </a:prstGeom>
           <a:solidFill>
-            <a:srgbClr val="9A3B2E"/>
+            <a:srgbClr val="7A5048"/>
           </a:solidFill>
           <a:ln w="12700">
             <a:solidFill>
@@ -20968,7 +20968,7 @@
             <a:avLst/>
           </a:prstGeom>
           <a:solidFill>
-            <a:srgbClr val="9A3B2E"/>
+            <a:srgbClr val="7A5048"/>
           </a:solidFill>
           <a:ln w="12700">
             <a:solidFill>
@@ -20993,7 +20993,7 @@
             <a:avLst/>
           </a:prstGeom>
           <a:solidFill>
-            <a:srgbClr val="9A3B2E"/>
+            <a:srgbClr val="7A5048"/>
           </a:solidFill>
           <a:ln w="12700">
             <a:solidFill>
@@ -21018,7 +21018,7 @@
             <a:avLst/>
           </a:prstGeom>
           <a:solidFill>
-            <a:srgbClr val="3D3F42"/>
+            <a:srgbClr val="4A4C4F"/>
           </a:solidFill>
           <a:ln w="12700">
             <a:solidFill>
@@ -21043,7 +21043,7 @@
             <a:avLst/>
           </a:prstGeom>
           <a:solidFill>
-            <a:srgbClr val="C4733F"/>
+            <a:srgbClr val="9C7360"/>
           </a:solidFill>
           <a:ln w="12700">
             <a:solidFill>
@@ -21068,7 +21068,7 @@
             <a:avLst/>
           </a:prstGeom>
           <a:solidFill>
-            <a:srgbClr val="C4733F"/>
+            <a:srgbClr val="9C7360"/>
           </a:solidFill>
           <a:ln w="12700">
             <a:solidFill>
@@ -21093,7 +21093,7 @@
             <a:avLst/>
           </a:prstGeom>
           <a:solidFill>
-            <a:srgbClr val="C4733F"/>
+            <a:srgbClr val="9C7360"/>
           </a:solidFill>
           <a:ln w="12700">
             <a:solidFill>
@@ -21118,7 +21118,7 @@
             <a:avLst/>
           </a:prstGeom>
           <a:solidFill>
-            <a:srgbClr val="C4733F"/>
+            <a:srgbClr val="9C7360"/>
           </a:solidFill>
           <a:ln w="12700">
             <a:solidFill>
@@ -21143,7 +21143,7 @@
             <a:avLst/>
           </a:prstGeom>
           <a:solidFill>
-            <a:srgbClr val="C4733F"/>
+            <a:srgbClr val="9C7360"/>
           </a:solidFill>
           <a:ln w="12700">
             <a:solidFill>
@@ -21168,7 +21168,7 @@
             <a:avLst/>
           </a:prstGeom>
           <a:solidFill>
-            <a:srgbClr val="C4733F"/>
+            <a:srgbClr val="9C7360"/>
           </a:solidFill>
           <a:ln w="12700">
             <a:solidFill>
@@ -21193,7 +21193,7 @@
             <a:avLst/>
           </a:prstGeom>
           <a:solidFill>
-            <a:srgbClr val="C4733F"/>
+            <a:srgbClr val="9C7360"/>
           </a:solidFill>
           <a:ln w="12700">
             <a:solidFill>
@@ -21218,7 +21218,7 @@
             <a:avLst/>
           </a:prstGeom>
           <a:solidFill>
-            <a:srgbClr val="5B8A96"/>
+            <a:srgbClr val="6F8790"/>
           </a:solidFill>
           <a:ln w="12700">
             <a:solidFill>
@@ -21243,7 +21243,7 @@
             <a:avLst/>
           </a:prstGeom>
           <a:solidFill>
-            <a:srgbClr val="5B8A96"/>
+            <a:srgbClr val="6F8790"/>
           </a:solidFill>
           <a:ln w="12700">
             <a:solidFill>
@@ -21268,7 +21268,7 @@
             <a:avLst/>
           </a:prstGeom>
           <a:solidFill>
-            <a:srgbClr val="8A6FC2"/>
+            <a:srgbClr val="857D97"/>
           </a:solidFill>
           <a:ln w="12700">
             <a:solidFill>
@@ -21293,7 +21293,7 @@
             <a:avLst/>
           </a:prstGeom>
           <a:solidFill>
-            <a:srgbClr val="C9A15E"/>
+            <a:srgbClr val="B29F7E"/>
           </a:solidFill>
           <a:ln w="12700">
             <a:solidFill>
@@ -21318,7 +21318,7 @@
             <a:avLst/>
           </a:prstGeom>
           <a:solidFill>
-            <a:srgbClr val="8FA3B3"/>
+            <a:srgbClr val="9AA6AD"/>
           </a:solidFill>
           <a:ln w="12700">
             <a:solidFill>
@@ -21343,7 +21343,7 @@
             <a:avLst/>
           </a:prstGeom>
           <a:solidFill>
-            <a:srgbClr val="6EA25A"/>
+            <a:srgbClr val="7D9180"/>
           </a:solidFill>
           <a:ln w="12700">
             <a:solidFill>
@@ -21372,7 +21372,7 @@
           </a:solidFill>
           <a:ln w="12700">
             <a:solidFill>
-              <a:srgbClr val="D08A1E"/>
+              <a:srgbClr val="A88A5C"/>
             </a:solidFill>
             <a:prstDash val="solid"/>
           </a:ln>
@@ -21397,7 +21397,7 @@
           </a:solidFill>
           <a:ln w="12700">
             <a:solidFill>
-              <a:srgbClr val="D08A1E"/>
+              <a:srgbClr val="A88A5C"/>
             </a:solidFill>
             <a:prstDash val="solid"/>
           </a:ln>
@@ -21422,7 +21422,7 @@
           </a:solidFill>
           <a:ln w="12700">
             <a:solidFill>
-              <a:srgbClr val="D08A1E"/>
+              <a:srgbClr val="A88A5C"/>
             </a:solidFill>
             <a:prstDash val="solid"/>
           </a:ln>
@@ -21447,7 +21447,7 @@
           </a:solidFill>
           <a:ln w="12700">
             <a:solidFill>
-              <a:srgbClr val="D08A1E"/>
+              <a:srgbClr val="A88A5C"/>
             </a:solidFill>
             <a:prstDash val="solid"/>
           </a:ln>
@@ -21472,7 +21472,7 @@
           </a:solidFill>
           <a:ln w="12700">
             <a:solidFill>
-              <a:srgbClr val="D08A1E"/>
+              <a:srgbClr val="A88A5C"/>
             </a:solidFill>
             <a:prstDash val="solid"/>
           </a:ln>
@@ -22138,7 +22138,7 @@
             <a:r>
               <a:rPr lang="en-US" sz="580" dirty="0">
                 <a:solidFill>
-                  <a:srgbClr val="9A3B2E"/>
+                  <a:srgbClr val="7A5048"/>
                 </a:solidFill>
                 <a:latin typeface="Yu Gothic" pitchFamily="34" charset="0"/>
                 <a:ea typeface="Yu Gothic" pitchFamily="34" charset="-122"/>
@@ -22172,7 +22172,7 @@
             <a:r>
               <a:rPr lang="en-US" sz="580" dirty="0">
                 <a:solidFill>
-                  <a:srgbClr val="3D3F42"/>
+                  <a:srgbClr val="4A4C4F"/>
                 </a:solidFill>
                 <a:latin typeface="Yu Gothic" pitchFamily="34" charset="0"/>
                 <a:ea typeface="Yu Gothic" pitchFamily="34" charset="-122"/>
@@ -22206,7 +22206,7 @@
             <a:r>
               <a:rPr lang="en-US" sz="580" dirty="0">
                 <a:solidFill>
-                  <a:srgbClr val="C4733F"/>
+                  <a:srgbClr val="9C7360"/>
                 </a:solidFill>
                 <a:latin typeface="Yu Gothic" pitchFamily="34" charset="0"/>
                 <a:ea typeface="Yu Gothic" pitchFamily="34" charset="-122"/>
@@ -22240,7 +22240,7 @@
             <a:r>
               <a:rPr lang="en-US" sz="580" dirty="0">
                 <a:solidFill>
-                  <a:srgbClr val="5B8A96"/>
+                  <a:srgbClr val="6F8790"/>
                 </a:solidFill>
                 <a:latin typeface="Yu Gothic" pitchFamily="34" charset="0"/>
                 <a:ea typeface="Yu Gothic" pitchFamily="34" charset="-122"/>
@@ -22274,7 +22274,7 @@
             <a:r>
               <a:rPr lang="en-US" sz="580" dirty="0">
                 <a:solidFill>
-                  <a:srgbClr val="8A6FC2"/>
+                  <a:srgbClr val="857D97"/>
                 </a:solidFill>
                 <a:latin typeface="Yu Gothic" pitchFamily="34" charset="0"/>
                 <a:ea typeface="Yu Gothic" pitchFamily="34" charset="-122"/>
@@ -22308,7 +22308,7 @@
             <a:r>
               <a:rPr lang="en-US" sz="580" dirty="0">
                 <a:solidFill>
-                  <a:srgbClr val="C9A15E"/>
+                  <a:srgbClr val="B29F7E"/>
                 </a:solidFill>
                 <a:latin typeface="Yu Gothic" pitchFamily="34" charset="0"/>
                 <a:ea typeface="Yu Gothic" pitchFamily="34" charset="-122"/>
@@ -22342,7 +22342,7 @@
             <a:r>
               <a:rPr lang="en-US" sz="580" dirty="0">
                 <a:solidFill>
-                  <a:srgbClr val="8FA3B3"/>
+                  <a:srgbClr val="9AA6AD"/>
                 </a:solidFill>
                 <a:latin typeface="Yu Gothic" pitchFamily="34" charset="0"/>
                 <a:ea typeface="Yu Gothic" pitchFamily="34" charset="-122"/>
@@ -22376,7 +22376,7 @@
             <a:r>
               <a:rPr lang="en-US" sz="580" dirty="0">
                 <a:solidFill>
-                  <a:srgbClr val="6EA25A"/>
+                  <a:srgbClr val="7D9180"/>
                 </a:solidFill>
                 <a:latin typeface="Yu Gothic" pitchFamily="34" charset="0"/>
                 <a:ea typeface="Yu Gothic" pitchFamily="34" charset="-122"/>
@@ -23326,7 +23326,7 @@
             <a:avLst/>
           </a:prstGeom>
           <a:solidFill>
-            <a:srgbClr val="1D6B73"/>
+            <a:srgbClr val="34494E"/>
           </a:solidFill>
           <a:ln/>
         </p:spPr>
@@ -23468,7 +23468,7 @@
             <a:avLst/>
           </a:prstGeom>
           <a:solidFill>
-            <a:srgbClr val="1D6B73"/>
+            <a:srgbClr val="34494E"/>
           </a:solidFill>
           <a:ln/>
         </p:spPr>
@@ -23610,7 +23610,7 @@
             <a:avLst/>
           </a:prstGeom>
           <a:solidFill>
-            <a:srgbClr val="1D6B73"/>
+            <a:srgbClr val="34494E"/>
           </a:solidFill>
           <a:ln/>
         </p:spPr>
@@ -23752,7 +23752,7 @@
             <a:avLst/>
           </a:prstGeom>
           <a:solidFill>
-            <a:srgbClr val="1D6B73"/>
+            <a:srgbClr val="34494E"/>
           </a:solidFill>
           <a:ln/>
         </p:spPr>
@@ -23835,7 +23835,7 @@
             <a:avLst/>
           </a:prstGeom>
           <a:solidFill>
-            <a:srgbClr val="1D6B73"/>
+            <a:srgbClr val="34494E"/>
           </a:solidFill>
           <a:ln/>
         </p:spPr>
@@ -23879,7 +23879,7 @@
             <a:avLst/>
           </a:prstGeom>
           <a:solidFill>
-            <a:srgbClr val="F4F9F9"/>
+            <a:srgbClr val="F6F7F6"/>
           </a:solidFill>
           <a:ln/>
         </p:spPr>
@@ -23899,7 +23899,7 @@
             <a:avLst/>
           </a:prstGeom>
           <a:solidFill>
-            <a:srgbClr val="D08A1E"/>
+            <a:srgbClr val="A88A5C"/>
           </a:solidFill>
           <a:ln/>
         </p:spPr>
@@ -23943,7 +23943,7 @@
             <a:avLst/>
           </a:prstGeom>
           <a:solidFill>
-            <a:srgbClr val="FDF8EF"/>
+            <a:srgbClr val="F9F6F1"/>
           </a:solidFill>
           <a:ln/>
         </p:spPr>
@@ -23963,7 +23963,7 @@
             <a:avLst/>
           </a:prstGeom>
           <a:solidFill>
-            <a:srgbClr val="6B5AA6"/>
+            <a:srgbClr val="7A7390"/>
           </a:solidFill>
           <a:ln/>
         </p:spPr>
@@ -24027,7 +24027,7 @@
             <a:avLst/>
           </a:prstGeom>
           <a:solidFill>
-            <a:srgbClr val="F8F7FC"/>
+            <a:srgbClr val="F7F6F8"/>
           </a:solidFill>
           <a:ln/>
         </p:spPr>
@@ -24047,7 +24047,7 @@
             <a:avLst/>
           </a:prstGeom>
           <a:solidFill>
-            <a:srgbClr val="1D6B73"/>
+            <a:srgbClr val="34494E"/>
           </a:solidFill>
           <a:ln/>
         </p:spPr>
@@ -24111,7 +24111,7 @@
             <a:avLst/>
           </a:prstGeom>
           <a:solidFill>
-            <a:srgbClr val="D08A1E"/>
+            <a:srgbClr val="A88A5C"/>
           </a:solidFill>
           <a:ln/>
         </p:spPr>
@@ -24155,7 +24155,7 @@
             <a:avLst/>
           </a:prstGeom>
           <a:solidFill>
-            <a:srgbClr val="D08A1E"/>
+            <a:srgbClr val="A88A5C"/>
           </a:solidFill>
           <a:ln/>
         </p:spPr>
@@ -24199,11 +24199,11 @@
             <a:avLst/>
           </a:prstGeom>
           <a:solidFill>
-            <a:srgbClr val="EFECF7"/>
+            <a:srgbClr val="F1F0F4"/>
           </a:solidFill>
           <a:ln w="12700">
             <a:solidFill>
-              <a:srgbClr val="6B5AA6"/>
+              <a:srgbClr val="7A7390"/>
             </a:solidFill>
             <a:prstDash val="solid"/>
           </a:ln>
@@ -24285,11 +24285,11 @@
             <a:avLst/>
           </a:prstGeom>
           <a:solidFill>
-            <a:srgbClr val="EFECF7"/>
+            <a:srgbClr val="F1F0F4"/>
           </a:solidFill>
           <a:ln w="12700">
             <a:solidFill>
-              <a:srgbClr val="6B5AA6"/>
+              <a:srgbClr val="7A7390"/>
             </a:solidFill>
             <a:prstDash val="solid"/>
           </a:ln>
@@ -24371,11 +24371,11 @@
             <a:avLst/>
           </a:prstGeom>
           <a:solidFill>
-            <a:srgbClr val="EFECF7"/>
+            <a:srgbClr val="F1F0F4"/>
           </a:solidFill>
           <a:ln w="12700">
             <a:solidFill>
-              <a:srgbClr val="6B5AA6"/>
+              <a:srgbClr val="7A7390"/>
             </a:solidFill>
             <a:prstDash val="solid"/>
           </a:ln>
@@ -24514,7 +24514,7 @@
             <a:r>
               <a:rPr lang="en-US" sz="600" dirty="0">
                 <a:solidFill>
-                  <a:srgbClr val="1D6B73"/>
+                  <a:srgbClr val="34494E"/>
                 </a:solidFill>
                 <a:latin typeface="Yu Gothic" pitchFamily="34" charset="0"/>
                 <a:ea typeface="Yu Gothic" pitchFamily="34" charset="-122"/>
@@ -24548,7 +24548,7 @@
             <a:r>
               <a:rPr lang="en-US" sz="600" dirty="0">
                 <a:solidFill>
-                  <a:srgbClr val="D08A1E"/>
+                  <a:srgbClr val="A88A5C"/>
                 </a:solidFill>
                 <a:latin typeface="Yu Gothic" pitchFamily="34" charset="0"/>
                 <a:ea typeface="Yu Gothic" pitchFamily="34" charset="-122"/>
@@ -24582,7 +24582,7 @@
             <a:r>
               <a:rPr lang="en-US" sz="600" dirty="0">
                 <a:solidFill>
-                  <a:srgbClr val="6B5AA6"/>
+                  <a:srgbClr val="7A7390"/>
                 </a:solidFill>
                 <a:latin typeface="Yu Gothic" pitchFamily="34" charset="0"/>
                 <a:ea typeface="Yu Gothic" pitchFamily="34" charset="-122"/>
@@ -24788,7 +24788,7 @@
         <p:spPr>
           <a:xfrm>
             <a:off x="3810000" y="10261600"/>
-            <a:ext cx="6180534" cy="152400"/>
+            <a:ext cx="5549900" cy="152400"/>
           </a:xfrm>
           <a:prstGeom prst="rect">
             <a:avLst/>
@@ -24814,7 +24814,7 @@
                 <a:ea typeface="Yu Gothic" pitchFamily="34" charset="-122"/>
                 <a:cs typeface="Yu Gothic" pitchFamily="34" charset="-120"/>
               </a:rPr>
-              <a:t>台割 完成版（構成確認用・PwC様レビュー10/2反映）— 青ラベル＝改善点／色は台割用（緑＝資源投資・橙＝トレーディング）で表紙3案とは無関係</a:t>
+              <a:t>台割 完成版（構成確認用・PwC様レビュー10/2反映）— 色は台割用（深緑＝資源投資・黄土＝トレーディング）で表紙3案とは無関係</a:t>
             </a:r>
             <a:endParaRPr lang="en-US" sz="660" dirty="0"/>
           </a:p>
@@ -25058,7 +25058,7 @@
             <a:avLst/>
           </a:prstGeom>
           <a:solidFill>
-            <a:srgbClr val="2A6FB0"/>
+            <a:srgbClr val="6D7D86"/>
           </a:solidFill>
           <a:ln/>
         </p:spPr>
@@ -25249,7 +25249,7 @@
             <a:avLst/>
           </a:prstGeom>
           <a:solidFill>
-            <a:srgbClr val="E8F3F3"/>
+            <a:srgbClr val="EEF1F0"/>
           </a:solidFill>
           <a:ln/>
         </p:spPr>
@@ -25295,7 +25295,7 @@
             </a:avLst>
           </a:prstGeom>
           <a:solidFill>
-            <a:srgbClr val="D08A1E"/>
+            <a:srgbClr val="A88A5C"/>
           </a:solidFill>
           <a:ln/>
         </p:spPr>
@@ -25440,7 +25440,7 @@
             <a:avLst/>
           </a:prstGeom>
           <a:solidFill>
-            <a:srgbClr val="E8F3F3"/>
+            <a:srgbClr val="EEF1F0"/>
           </a:solidFill>
           <a:ln/>
         </p:spPr>
@@ -25486,7 +25486,7 @@
             </a:avLst>
           </a:prstGeom>
           <a:solidFill>
-            <a:srgbClr val="D08A1E"/>
+            <a:srgbClr val="A88A5C"/>
           </a:solidFill>
           <a:ln/>
         </p:spPr>
@@ -25631,7 +25631,7 @@
             <a:avLst/>
           </a:prstGeom>
           <a:solidFill>
-            <a:srgbClr val="E8F3F3"/>
+            <a:srgbClr val="EEF1F0"/>
           </a:solidFill>
           <a:ln/>
         </p:spPr>
@@ -25677,7 +25677,7 @@
             </a:avLst>
           </a:prstGeom>
           <a:solidFill>
-            <a:srgbClr val="D08A1E"/>
+            <a:srgbClr val="A88A5C"/>
           </a:solidFill>
           <a:ln/>
         </p:spPr>
@@ -25822,7 +25822,7 @@
             <a:avLst/>
           </a:prstGeom>
           <a:solidFill>
-            <a:srgbClr val="E8F3F3"/>
+            <a:srgbClr val="EEF1F0"/>
           </a:solidFill>
           <a:ln/>
         </p:spPr>
@@ -25868,7 +25868,7 @@
             </a:avLst>
           </a:prstGeom>
           <a:solidFill>
-            <a:srgbClr val="D08A1E"/>
+            <a:srgbClr val="A88A5C"/>
           </a:solidFill>
           <a:ln/>
         </p:spPr>
@@ -26078,7 +26078,7 @@
             <a:avLst/>
           </a:prstGeom>
           <a:solidFill>
-            <a:srgbClr val="3D3F42"/>
+            <a:srgbClr val="4A4C4F"/>
           </a:solidFill>
           <a:ln/>
         </p:spPr>
@@ -26119,7 +26119,7 @@
             <a:avLst/>
           </a:prstGeom>
           <a:solidFill>
-            <a:srgbClr val="3D3F42"/>
+            <a:srgbClr val="4A4C4F"/>
           </a:solidFill>
           <a:ln/>
         </p:spPr>
@@ -26160,7 +26160,7 @@
             <a:avLst/>
           </a:prstGeom>
           <a:solidFill>
-            <a:srgbClr val="3D3F42"/>
+            <a:srgbClr val="4A4C4F"/>
           </a:solidFill>
           <a:ln/>
         </p:spPr>
@@ -26267,7 +26267,7 @@
             <a:avLst/>
           </a:prstGeom>
           <a:solidFill>
-            <a:srgbClr val="FBF0DD"/>
+            <a:srgbClr val="F5F0E8"/>
           </a:solidFill>
           <a:ln/>
         </p:spPr>
@@ -26377,7 +26377,7 @@
             <a:avLst/>
           </a:prstGeom>
           <a:solidFill>
-            <a:srgbClr val="FBF0DD"/>
+            <a:srgbClr val="F5F0E8"/>
           </a:solidFill>
           <a:ln/>
         </p:spPr>
@@ -26487,7 +26487,7 @@
             <a:avLst/>
           </a:prstGeom>
           <a:solidFill>
-            <a:srgbClr val="FBF0DD"/>
+            <a:srgbClr val="F5F0E8"/>
           </a:solidFill>
           <a:ln/>
         </p:spPr>
@@ -26660,7 +26660,7 @@
           <a:noFill/>
           <a:ln w="25400">
             <a:solidFill>
-              <a:srgbClr val="1D6B73"/>
+              <a:srgbClr val="34494E"/>
             </a:solidFill>
             <a:prstDash val="solid"/>
           </a:ln>
@@ -26696,7 +26696,7 @@
             <a:r>
               <a:rPr lang="en-US" sz="900" b="1" dirty="0">
                 <a:solidFill>
-                  <a:srgbClr val="1D6B73"/>
+                  <a:srgbClr val="34494E"/>
                 </a:solidFill>
                 <a:latin typeface="Yu Gothic" pitchFamily="34" charset="0"/>
                 <a:ea typeface="Yu Gothic" pitchFamily="34" charset="-122"/>
@@ -26767,7 +26767,7 @@
           <a:noFill/>
           <a:ln w="25400">
             <a:solidFill>
-              <a:srgbClr val="1D6B73"/>
+              <a:srgbClr val="34494E"/>
             </a:solidFill>
             <a:prstDash val="solid"/>
           </a:ln>
@@ -26803,7 +26803,7 @@
             <a:r>
               <a:rPr lang="en-US" sz="900" b="1" dirty="0">
                 <a:solidFill>
-                  <a:srgbClr val="1D6B73"/>
+                  <a:srgbClr val="34494E"/>
                 </a:solidFill>
                 <a:latin typeface="Yu Gothic" pitchFamily="34" charset="0"/>
                 <a:ea typeface="Yu Gothic" pitchFamily="34" charset="-122"/>
@@ -26874,7 +26874,7 @@
           <a:noFill/>
           <a:ln w="25400">
             <a:solidFill>
-              <a:srgbClr val="1D6B73"/>
+              <a:srgbClr val="34494E"/>
             </a:solidFill>
             <a:prstDash val="solid"/>
           </a:ln>
@@ -26910,7 +26910,7 @@
             <a:r>
               <a:rPr lang="en-US" sz="900" b="1" dirty="0">
                 <a:solidFill>
-                  <a:srgbClr val="1D6B73"/>
+                  <a:srgbClr val="34494E"/>
                 </a:solidFill>
                 <a:latin typeface="Yu Gothic" pitchFamily="34" charset="0"/>
                 <a:ea typeface="Yu Gothic" pitchFamily="34" charset="-122"/>
@@ -27238,7 +27238,7 @@
             <a:avLst/>
           </a:prstGeom>
           <a:solidFill>
-            <a:srgbClr val="E8F3F3"/>
+            <a:srgbClr val="EEF1F0"/>
           </a:solidFill>
           <a:ln/>
         </p:spPr>
@@ -27260,7 +27260,7 @@
             </a:avLst>
           </a:prstGeom>
           <a:solidFill>
-            <a:srgbClr val="1D6B73"/>
+            <a:srgbClr val="34494E"/>
           </a:solidFill>
           <a:ln/>
         </p:spPr>
@@ -27731,7 +27731,7 @@
             <a:avLst/>
           </a:prstGeom>
           <a:solidFill>
-            <a:srgbClr val="1D6B73"/>
+            <a:srgbClr val="34494E"/>
           </a:solidFill>
           <a:ln/>
         </p:spPr>
@@ -27837,7 +27837,7 @@
             <a:avLst/>
           </a:prstGeom>
           <a:solidFill>
-            <a:srgbClr val="D08A1E"/>
+            <a:srgbClr val="A88A5C"/>
           </a:solidFill>
           <a:ln/>
         </p:spPr>
@@ -28151,7 +28151,7 @@
             <a:avLst/>
           </a:prstGeom>
           <a:solidFill>
-            <a:srgbClr val="2A6FB0"/>
+            <a:srgbClr val="6D7D86"/>
           </a:solidFill>
           <a:ln/>
         </p:spPr>
@@ -28766,7 +28766,7 @@
             <a:avLst/>
           </a:prstGeom>
           <a:solidFill>
-            <a:srgbClr val="2A6FB0"/>
+            <a:srgbClr val="6D7D86"/>
           </a:solidFill>
           <a:ln/>
         </p:spPr>
@@ -29080,7 +29080,7 @@
         <p:spPr>
           <a:xfrm>
             <a:off x="3810000" y="10261600"/>
-            <a:ext cx="6180534" cy="152400"/>
+            <a:ext cx="5549900" cy="152400"/>
           </a:xfrm>
           <a:prstGeom prst="rect">
             <a:avLst/>
@@ -29106,7 +29106,7 @@
                 <a:ea typeface="Yu Gothic" pitchFamily="34" charset="-122"/>
                 <a:cs typeface="Yu Gothic" pitchFamily="34" charset="-120"/>
               </a:rPr>
-              <a:t>台割 完成版（構成確認用・PwC様レビュー10/2反映）— 青ラベル＝改善点／色は台割用（緑＝資源投資・橙＝トレーディング）で表紙3案とは無関係</a:t>
+              <a:t>台割 完成版（構成確認用・PwC様レビュー10/2反映）— 色は台割用（深緑＝資源投資・黄土＝トレーディング）で表紙3案とは無関係</a:t>
             </a:r>
             <a:endParaRPr lang="en-US" sz="660" dirty="0"/>
           </a:p>

</xml_diff>